<commit_message>
Align deck with DEMO.md: intelligence-3-ways + Domain-3-layers (5 slides)
Reworked slide 3 to "intelligence, three ways" (Aura Copilot / Embedded Aura /
Aura Code on one context engine) and added a dedicated "One Domain · three layers"
slide (SingleStore expertise / business ontology / auto technical semantic).
Updated both the HTML deck and the editable PPTX exporter (now 5 slides).

Co-Authored-By: Claude Opus 4.8 <noreply@anthropic.com>
</commit_message>
<xml_diff>
--- a/WealthPulse-Aura-Deck.pptx
+++ b/WealthPulse-Aura-Deck.pptx
@@ -9,9 +9,10 @@
     <p:sldId id="257" r:id="rId3"/>
     <p:sldId id="258" r:id="rId4"/>
     <p:sldId id="259" r:id="rId5"/>
+    <p:sldId id="260" r:id="rId6"/>
   </p:sldIdLst>
   <p:notesMasterIdLst>
-    <p:notesMasterId r:id="rId6"/>
+    <p:notesMasterId r:id="rId7"/>
   </p:notesMasterIdLst>
   <p:sldSz cx="12191695" cy="6858000"/>
   <p:notesSz cx="6858000" cy="12191695"/>
@@ -793,6 +794,94 @@
             <a:fld id="{F7021451-1387-4CA6-816F-3879F97B5CBC}" type="slidenum">
               <a:rPr lang="en-US"/>
               <a:t>4</a:t>
+            </a:fld>
+            <a:endParaRPr lang="en-US"/>
+          </a:p>
+        </p:txBody>
+      </p:sp>
+    </p:spTree>
+    <p:extLst>
+      <p:ext uri="{BB962C8B-B14F-4D97-AF65-F5344CB8AC3E}">
+        <p14:creationId xmlns:p14="http://schemas.microsoft.com/office/powerpoint/2010/main" val="1024086991"/>
+      </p:ext>
+    </p:extLst>
+  </p:cSld>
+  <p:clrMapOvr>
+    <a:masterClrMapping/>
+  </p:clrMapOvr>
+</p:notes>
+</file>
+
+<file path=ppt/notesSlides/notesSlide5.xml><?xml version="1.0" encoding="utf-8"?>
+<p:notes xmlns:a="http://schemas.openxmlformats.org/drawingml/2006/main" xmlns:r="http://schemas.openxmlformats.org/officeDocument/2006/relationships" xmlns:p="http://schemas.openxmlformats.org/presentationml/2006/main">
+  <p:cSld>
+    <p:spTree>
+      <p:nvGrpSpPr>
+        <p:cNvPr id="1" name=""/>
+        <p:cNvGrpSpPr/>
+        <p:nvPr/>
+      </p:nvGrpSpPr>
+      <p:grpSpPr>
+        <a:xfrm>
+          <a:off x="0" y="0"/>
+          <a:ext cx="0" cy="0"/>
+          <a:chOff x="0" y="0"/>
+          <a:chExt cx="0" cy="0"/>
+        </a:xfrm>
+      </p:grpSpPr>
+      <p:sp>
+        <p:nvSpPr>
+          <p:cNvPr id="2" name="Slide Image Placeholder 1"/>
+          <p:cNvSpPr>
+            <a:spLocks noGrp="1" noRot="1" noChangeAspect="1"/>
+          </p:cNvSpPr>
+          <p:nvPr>
+            <p:ph type="sldImg"/>
+          </p:nvPr>
+        </p:nvSpPr>
+        <p:spPr/>
+      </p:sp>
+      <p:sp>
+        <p:nvSpPr>
+          <p:cNvPr id="3" name="Notes Placeholder 2"/>
+          <p:cNvSpPr>
+            <a:spLocks noGrp="1"/>
+          </p:cNvSpPr>
+          <p:nvPr>
+            <p:ph type="body" idx="1"/>
+          </p:nvPr>
+        </p:nvSpPr>
+        <p:spPr/>
+        <p:txBody>
+          <a:bodyPr/>
+          <a:lstStyle/>
+          <a:p>
+            <a:r>
+              <a:rPr lang="en-US" dirty="0"/>
+              <a:t/>
+            </a:r>
+            <a:endParaRPr lang="en-US" dirty="0"/>
+          </a:p>
+        </p:txBody>
+      </p:sp>
+      <p:sp>
+        <p:nvSpPr>
+          <p:cNvPr id="4" name="Slide Number Placeholder 3"/>
+          <p:cNvSpPr>
+            <a:spLocks noGrp="1"/>
+          </p:cNvSpPr>
+          <p:nvPr>
+            <p:ph type="sldNum" sz="quarter" idx="10"/>
+          </p:nvPr>
+        </p:nvSpPr>
+        <p:spPr/>
+        <p:txBody>
+          <a:bodyPr/>
+          <a:lstStyle/>
+          <a:p>
+            <a:fld id="{F7021451-1387-4CA6-816F-3879F97B5CBC}" type="slidenum">
+              <a:rPr lang="en-US"/>
+              <a:t>5</a:t>
             </a:fld>
             <a:endParaRPr lang="en-US"/>
           </a:p>
@@ -2037,7 +2126,7 @@
                 <a:ea typeface="Arial" pitchFamily="34" charset="-122"/>
                 <a:cs typeface="Arial" pitchFamily="34" charset="-120"/>
               </a:rPr>
-              <a:t>WHAT YOU'RE WATCHING</a:t>
+              <a:t>AURA · THREE OFFERINGS, ONE CONTEXT ENGINE</a:t>
             </a:r>
             <a:endParaRPr lang="en-US" sz="1250" dirty="0"/>
           </a:p>
@@ -2051,7 +2140,7 @@
         </p:nvSpPr>
         <p:spPr>
           <a:xfrm>
-            <a:off x="658368" y="1051560"/>
+            <a:off x="658368" y="1005840"/>
             <a:ext cx="10972800" cy="1371600"/>
           </a:xfrm>
           <a:prstGeom prst="rect">
@@ -2066,12 +2155,12 @@
           <a:p>
             <a:pPr indent="0" marL="0">
               <a:lnSpc>
-                <a:spcPts val="4080"/>
+                <a:spcPts val="3468"/>
               </a:lnSpc>
               <a:buNone/>
             </a:pPr>
             <a:r>
-              <a:rPr lang="en-US" sz="4000" b="1" dirty="0">
+              <a:rPr lang="en-US" sz="3400" b="1" dirty="0">
                 <a:solidFill>
                   <a:srgbClr val="E9EEF7"/>
                 </a:solidFill>
@@ -2079,16 +2168,16 @@
                 <a:ea typeface="Arial" pitchFamily="34" charset="-122"/>
                 <a:cs typeface="Arial" pitchFamily="34" charset="-120"/>
               </a:rPr>
-              <a:t>WealthPulse is </a:t>
+              <a:t>Your app on SingleStore — now </a:t>
             </a:r>
             <a:pPr indent="0" marL="0">
               <a:lnSpc>
-                <a:spcPts val="4080"/>
+                <a:spcPts val="3468"/>
               </a:lnSpc>
               <a:buNone/>
             </a:pPr>
             <a:r>
-              <a:rPr lang="en-US" sz="4000" b="1" dirty="0">
+              <a:rPr lang="en-US" sz="3400" b="1" dirty="0">
                 <a:solidFill>
                   <a:srgbClr val="D8B25A"/>
                 </a:solidFill>
@@ -2096,43 +2185,68 @@
                 <a:ea typeface="Arial" pitchFamily="34" charset="-122"/>
                 <a:cs typeface="Arial" pitchFamily="34" charset="-120"/>
               </a:rPr>
-              <a:t>Embedded Aura</a:t>
-            </a:r>
+              <a:t>intelligence, three ways.</a:t>
+            </a:r>
+            <a:endParaRPr lang="en-US" sz="3400" dirty="0"/>
+          </a:p>
+        </p:txBody>
+      </p:sp>
+      <p:sp>
+        <p:nvSpPr>
+          <p:cNvPr id="4" name="Text 2"/>
+          <p:cNvSpPr/>
+          <p:nvPr/>
+        </p:nvSpPr>
+        <p:spPr>
+          <a:xfrm>
+            <a:off x="658368" y="1783080"/>
+            <a:ext cx="10972800" cy="457200"/>
+          </a:xfrm>
+          <a:prstGeom prst="rect">
+            <a:avLst/>
+          </a:prstGeom>
+          <a:noFill/>
+          <a:ln/>
+        </p:spPr>
+        <p:txBody>
+          <a:bodyPr wrap="square" rtlCol="0" anchor="ctr"/>
+          <a:lstStyle/>
+          <a:p>
             <a:pPr indent="0" marL="0">
               <a:lnSpc>
-                <a:spcPts val="4080"/>
+                <a:spcPct val="130000"/>
               </a:lnSpc>
               <a:buNone/>
             </a:pPr>
             <a:r>
-              <a:rPr lang="en-US" sz="4000" b="1" dirty="0">
-                <a:solidFill>
-                  <a:srgbClr val="E9EEF7"/>
-                </a:solidFill>
-                <a:latin typeface="Arial" pitchFamily="34" charset="0"/>
-                <a:ea typeface="Arial" pitchFamily="34" charset="-122"/>
-                <a:cs typeface="Arial" pitchFamily="34" charset="-120"/>
-              </a:rPr>
-              <a:t> on live context.</a:t>
-            </a:r>
-            <a:endParaRPr lang="en-US" sz="4000" dirty="0"/>
-          </a:p>
-        </p:txBody>
-      </p:sp>
-      <p:sp>
-        <p:nvSpPr>
-          <p:cNvPr id="4" name="Shape 2"/>
-          <p:cNvSpPr/>
-          <p:nvPr/>
-        </p:nvSpPr>
-        <p:spPr>
-          <a:xfrm>
-            <a:off x="658368" y="2240280"/>
-            <a:ext cx="5257800" cy="1234440"/>
+              <a:rPr lang="en-US" sz="1500" dirty="0">
+                <a:solidFill>
+                  <a:srgbClr val="C3CCDC"/>
+                </a:solidFill>
+                <a:latin typeface="Arial" pitchFamily="34" charset="0"/>
+                <a:ea typeface="Arial" pitchFamily="34" charset="-122"/>
+                <a:cs typeface="Arial" pitchFamily="34" charset="-120"/>
+              </a:rPr>
+              <a:t>Real-time data is the foundation. Put best-in-class intelligence on top — one copy of data, one Domain, one context engine.</a:t>
+            </a:r>
+            <a:endParaRPr lang="en-US" sz="1500" dirty="0"/>
+          </a:p>
+        </p:txBody>
+      </p:sp>
+      <p:sp>
+        <p:nvSpPr>
+          <p:cNvPr id="5" name="Shape 3"/>
+          <p:cNvSpPr/>
+          <p:nvPr/>
+        </p:nvSpPr>
+        <p:spPr>
+          <a:xfrm>
+            <a:off x="658368" y="2514600"/>
+            <a:ext cx="3566160" cy="2240280"/>
           </a:xfrm>
           <a:prstGeom prst="roundRect">
             <a:avLst>
-              <a:gd name="adj" fmla="val 8889"/>
+              <a:gd name="adj" fmla="val 4898"/>
             </a:avLst>
           </a:prstGeom>
           <a:solidFill>
@@ -2148,14 +2262,14 @@
       </p:sp>
       <p:sp>
         <p:nvSpPr>
-          <p:cNvPr id="5" name="Text 3"/>
-          <p:cNvSpPr/>
-          <p:nvPr/>
-        </p:nvSpPr>
-        <p:spPr>
-          <a:xfrm>
-            <a:off x="932688" y="2423160"/>
-            <a:ext cx="4709160" cy="274320"/>
+          <p:cNvPr id="6" name="Text 4"/>
+          <p:cNvSpPr/>
+          <p:nvPr/>
+        </p:nvSpPr>
+        <p:spPr>
+          <a:xfrm>
+            <a:off x="914400" y="2752344"/>
+            <a:ext cx="3108960" cy="274320"/>
           </a:xfrm>
           <a:prstGeom prst="rect">
             <a:avLst/>
@@ -2171,15 +2285,15 @@
               <a:buNone/>
             </a:pPr>
             <a:r>
-              <a:rPr lang="en-US" sz="1100" b="1" spc="200" kern="0" dirty="0">
-                <a:solidFill>
-                  <a:srgbClr val="D8B25A"/>
-                </a:solidFill>
-                <a:latin typeface="Arial" pitchFamily="34" charset="0"/>
-                <a:ea typeface="Arial" pitchFamily="34" charset="-122"/>
-                <a:cs typeface="Arial" pitchFamily="34" charset="-120"/>
-              </a:rPr>
-              <a:t>ONE GOVERNED SINGLESTORE DATABASE</a:t>
+              <a:rPr lang="en-US" sz="1100" b="1" spc="150" kern="0" dirty="0">
+                <a:solidFill>
+                  <a:srgbClr val="C4B5FD"/>
+                </a:solidFill>
+                <a:latin typeface="Arial" pitchFamily="34" charset="0"/>
+                <a:ea typeface="Arial" pitchFamily="34" charset="-122"/>
+                <a:cs typeface="Arial" pitchFamily="34" charset="-120"/>
+              </a:rPr>
+              <a:t>HEADED</a:t>
             </a:r>
             <a:endParaRPr lang="en-US" sz="1100" dirty="0"/>
           </a:p>
@@ -2187,14 +2301,14 @@
       </p:sp>
       <p:sp>
         <p:nvSpPr>
-          <p:cNvPr id="6" name="Text 4"/>
-          <p:cNvSpPr/>
-          <p:nvPr/>
-        </p:nvSpPr>
-        <p:spPr>
-          <a:xfrm>
-            <a:off x="932688" y="2788920"/>
-            <a:ext cx="4709160" cy="548640"/>
+          <p:cNvPr id="7" name="Text 5"/>
+          <p:cNvSpPr/>
+          <p:nvPr/>
+        </p:nvSpPr>
+        <p:spPr>
+          <a:xfrm>
+            <a:off x="914400" y="3118104"/>
+            <a:ext cx="3108960" cy="365760"/>
           </a:xfrm>
           <a:prstGeom prst="rect">
             <a:avLst/>
@@ -2210,142 +2324,76 @@
               <a:buNone/>
             </a:pPr>
             <a:r>
-              <a:rPr lang="en-US" sz="1450" dirty="0">
-                <a:solidFill>
-                  <a:srgbClr val="C3CCDC"/>
-                </a:solidFill>
-                <a:latin typeface="Arial" pitchFamily="34" charset="0"/>
-                <a:ea typeface="Arial" pitchFamily="34" charset="-122"/>
-                <a:cs typeface="Arial" pitchFamily="34" charset="-120"/>
-              </a:rPr>
-              <a:t>Transactions  ·  Analytics  ·  Search  ·  one copy, live</a:t>
-            </a:r>
-            <a:endParaRPr lang="en-US" sz="1450" dirty="0"/>
-          </a:p>
-        </p:txBody>
-      </p:sp>
-      <p:sp>
-        <p:nvSpPr>
-          <p:cNvPr id="7" name="Shape 5"/>
-          <p:cNvSpPr/>
-          <p:nvPr/>
-        </p:nvSpPr>
-        <p:spPr>
-          <a:xfrm>
-            <a:off x="6236208" y="2240280"/>
-            <a:ext cx="5257800" cy="1234440"/>
+              <a:rPr lang="en-US" sz="1800" b="1" dirty="0">
+                <a:solidFill>
+                  <a:srgbClr val="E9EEF7"/>
+                </a:solidFill>
+                <a:latin typeface="Arial" pitchFamily="34" charset="0"/>
+                <a:ea typeface="Arial" pitchFamily="34" charset="-122"/>
+                <a:cs typeface="Arial" pitchFamily="34" charset="-120"/>
+              </a:rPr>
+              <a:t>Aura Copilot</a:t>
+            </a:r>
+            <a:endParaRPr lang="en-US" sz="1800" dirty="0"/>
+          </a:p>
+        </p:txBody>
+      </p:sp>
+      <p:sp>
+        <p:nvSpPr>
+          <p:cNvPr id="8" name="Text 6"/>
+          <p:cNvSpPr/>
+          <p:nvPr/>
+        </p:nvSpPr>
+        <p:spPr>
+          <a:xfrm>
+            <a:off x="914400" y="3593592"/>
+            <a:ext cx="3108960" cy="1005840"/>
+          </a:xfrm>
+          <a:prstGeom prst="rect">
+            <a:avLst/>
+          </a:prstGeom>
+          <a:noFill/>
+          <a:ln/>
+        </p:spPr>
+        <p:txBody>
+          <a:bodyPr wrap="square" rtlCol="0" anchor="t"/>
+          <a:lstStyle/>
+          <a:p>
+            <a:pPr indent="0" marL="0">
+              <a:lnSpc>
+                <a:spcPct val="130000"/>
+              </a:lnSpc>
+              <a:buNone/>
+            </a:pPr>
+            <a:r>
+              <a:rPr lang="en-US" sz="1350" dirty="0">
+                <a:solidFill>
+                  <a:srgbClr val="8B95AB"/>
+                </a:solidFill>
+                <a:latin typeface="Arial" pitchFamily="34" charset="0"/>
+                <a:ea typeface="Arial" pitchFamily="34" charset="-122"/>
+                <a:cs typeface="Arial" pitchFamily="34" charset="-120"/>
+              </a:rPr>
+              <a:t>Analysts &amp; BI at analyst.singlestore.com. Dashboards &amp; sharing. Zero build.</a:t>
+            </a:r>
+            <a:endParaRPr lang="en-US" sz="1350" dirty="0"/>
+          </a:p>
+        </p:txBody>
+      </p:sp>
+      <p:sp>
+        <p:nvSpPr>
+          <p:cNvPr id="9" name="Shape 7"/>
+          <p:cNvSpPr/>
+          <p:nvPr/>
+        </p:nvSpPr>
+        <p:spPr>
+          <a:xfrm>
+            <a:off x="4498848" y="2514600"/>
+            <a:ext cx="3566160" cy="2240280"/>
           </a:xfrm>
           <a:prstGeom prst="roundRect">
             <a:avLst>
-              <a:gd name="adj" fmla="val 8889"/>
-            </a:avLst>
-          </a:prstGeom>
-          <a:solidFill>
-            <a:srgbClr val="15161E"/>
-          </a:solidFill>
-          <a:ln w="12700">
-            <a:solidFill>
-              <a:srgbClr val="D8B25A"/>
-            </a:solidFill>
-            <a:prstDash val="solid"/>
-          </a:ln>
-        </p:spPr>
-      </p:sp>
-      <p:sp>
-        <p:nvSpPr>
-          <p:cNvPr id="8" name="Text 6"/>
-          <p:cNvSpPr/>
-          <p:nvPr/>
-        </p:nvSpPr>
-        <p:spPr>
-          <a:xfrm>
-            <a:off x="6510528" y="2423160"/>
-            <a:ext cx="4709160" cy="274320"/>
-          </a:xfrm>
-          <a:prstGeom prst="rect">
-            <a:avLst/>
-          </a:prstGeom>
-          <a:noFill/>
-          <a:ln/>
-        </p:spPr>
-        <p:txBody>
-          <a:bodyPr wrap="square" rtlCol="0" anchor="ctr"/>
-          <a:lstStyle/>
-          <a:p>
-            <a:pPr indent="0" marL="0">
-              <a:buNone/>
-            </a:pPr>
-            <a:r>
-              <a:rPr lang="en-US" sz="1100" b="1" spc="150" kern="0" dirty="0">
-                <a:solidFill>
-                  <a:srgbClr val="D8B25A"/>
-                </a:solidFill>
-                <a:latin typeface="Arial" pitchFamily="34" charset="0"/>
-                <a:ea typeface="Arial" pitchFamily="34" charset="-122"/>
-                <a:cs typeface="Arial" pitchFamily="34" charset="-120"/>
-              </a:rPr>
-              <a:t>SINGLESTORE CONTEXT ENGINE · KNOWLEDGE FABRIC</a:t>
-            </a:r>
-            <a:endParaRPr lang="en-US" sz="1100" dirty="0"/>
-          </a:p>
-        </p:txBody>
-      </p:sp>
-      <p:sp>
-        <p:nvSpPr>
-          <p:cNvPr id="9" name="Text 7"/>
-          <p:cNvSpPr/>
-          <p:nvPr/>
-        </p:nvSpPr>
-        <p:spPr>
-          <a:xfrm>
-            <a:off x="6510528" y="2788920"/>
-            <a:ext cx="4709160" cy="594360"/>
-          </a:xfrm>
-          <a:prstGeom prst="rect">
-            <a:avLst/>
-          </a:prstGeom>
-          <a:noFill/>
-          <a:ln/>
-        </p:spPr>
-        <p:txBody>
-          <a:bodyPr wrap="square" rtlCol="0" anchor="ctr"/>
-          <a:lstStyle/>
-          <a:p>
-            <a:pPr indent="0" marL="0">
-              <a:lnSpc>
-                <a:spcPct val="120000"/>
-              </a:lnSpc>
-              <a:buNone/>
-            </a:pPr>
-            <a:r>
-              <a:rPr lang="en-US" sz="1300" dirty="0">
-                <a:solidFill>
-                  <a:srgbClr val="C3CCDC"/>
-                </a:solidFill>
-                <a:latin typeface="Arial" pitchFamily="34" charset="0"/>
-                <a:ea typeface="Arial" pitchFamily="34" charset="-122"/>
-                <a:cs typeface="Arial" pitchFamily="34" charset="-120"/>
-              </a:rPr>
-              <a:t>Business ontology  ·  schema crawling  ·  data sampling  ·  feedback loop  ·  model gateway (BYOK)</a:t>
-            </a:r>
-            <a:endParaRPr lang="en-US" sz="1300" dirty="0"/>
-          </a:p>
-        </p:txBody>
-      </p:sp>
-      <p:sp>
-        <p:nvSpPr>
-          <p:cNvPr id="10" name="Shape 8"/>
-          <p:cNvSpPr/>
-          <p:nvPr/>
-        </p:nvSpPr>
-        <p:spPr>
-          <a:xfrm>
-            <a:off x="658368" y="3749040"/>
-            <a:ext cx="10835640" cy="960120"/>
-          </a:xfrm>
-          <a:prstGeom prst="roundRect">
-            <a:avLst>
-              <a:gd name="adj" fmla="val 11429"/>
+              <a:gd name="adj" fmla="val 4898"/>
             </a:avLst>
           </a:prstGeom>
           <a:solidFill>
@@ -2361,14 +2409,53 @@
       </p:sp>
       <p:sp>
         <p:nvSpPr>
+          <p:cNvPr id="10" name="Text 8"/>
+          <p:cNvSpPr/>
+          <p:nvPr/>
+        </p:nvSpPr>
+        <p:spPr>
+          <a:xfrm>
+            <a:off x="4754880" y="2752344"/>
+            <a:ext cx="3108960" cy="274320"/>
+          </a:xfrm>
+          <a:prstGeom prst="rect">
+            <a:avLst/>
+          </a:prstGeom>
+          <a:noFill/>
+          <a:ln/>
+        </p:spPr>
+        <p:txBody>
+          <a:bodyPr wrap="square" rtlCol="0" anchor="ctr"/>
+          <a:lstStyle/>
+          <a:p>
+            <a:pPr indent="0" marL="0">
+              <a:buNone/>
+            </a:pPr>
+            <a:r>
+              <a:rPr lang="en-US" sz="1100" b="1" spc="150" kern="0" dirty="0">
+                <a:solidFill>
+                  <a:srgbClr val="FDBA74"/>
+                </a:solidFill>
+                <a:latin typeface="Arial" pitchFamily="34" charset="0"/>
+                <a:ea typeface="Arial" pitchFamily="34" charset="-122"/>
+                <a:cs typeface="Arial" pitchFamily="34" charset="-120"/>
+              </a:rPr>
+              <a:t>HEADLESS</a:t>
+            </a:r>
+            <a:endParaRPr lang="en-US" sz="1100" dirty="0"/>
+          </a:p>
+        </p:txBody>
+      </p:sp>
+      <p:sp>
+        <p:nvSpPr>
           <p:cNvPr id="11" name="Text 9"/>
           <p:cNvSpPr/>
           <p:nvPr/>
         </p:nvSpPr>
         <p:spPr>
           <a:xfrm>
-            <a:off x="932688" y="3913632"/>
-            <a:ext cx="10058400" cy="274320"/>
+            <a:off x="4754880" y="3118104"/>
+            <a:ext cx="3108960" cy="365760"/>
           </a:xfrm>
           <a:prstGeom prst="rect">
             <a:avLst/>
@@ -2384,17 +2471,17 @@
               <a:buNone/>
             </a:pPr>
             <a:r>
-              <a:rPr lang="en-US" sz="1100" b="1" spc="200" kern="0" dirty="0">
-                <a:solidFill>
-                  <a:srgbClr val="D8B25A"/>
-                </a:solidFill>
-                <a:latin typeface="Arial" pitchFamily="34" charset="0"/>
-                <a:ea typeface="Arial" pitchFamily="34" charset="-122"/>
-                <a:cs typeface="Arial" pitchFamily="34" charset="-120"/>
-              </a:rPr>
-              <a:t>ONE CONTEXT ENGINE  →  THREE OFFERINGS</a:t>
-            </a:r>
-            <a:endParaRPr lang="en-US" sz="1100" dirty="0"/>
+              <a:rPr lang="en-US" sz="1800" b="1" dirty="0">
+                <a:solidFill>
+                  <a:srgbClr val="E9EEF7"/>
+                </a:solidFill>
+                <a:latin typeface="Arial" pitchFamily="34" charset="0"/>
+                <a:ea typeface="Arial" pitchFamily="34" charset="-122"/>
+                <a:cs typeface="Arial" pitchFamily="34" charset="-120"/>
+              </a:rPr>
+              <a:t>Embedded Aura</a:t>
+            </a:r>
+            <a:endParaRPr lang="en-US" sz="1800" dirty="0"/>
           </a:p>
         </p:txBody>
       </p:sp>
@@ -2406,61 +2493,8 @@
         </p:nvSpPr>
         <p:spPr>
           <a:xfrm>
-            <a:off x="932688" y="4251960"/>
-            <a:ext cx="10332720" cy="365760"/>
-          </a:xfrm>
-          <a:prstGeom prst="rect">
-            <a:avLst/>
-          </a:prstGeom>
-          <a:noFill/>
-          <a:ln/>
-        </p:spPr>
-        <p:txBody>
-          <a:bodyPr wrap="square" rtlCol="0" anchor="ctr"/>
-          <a:lstStyle/>
-          <a:p>
-            <a:pPr indent="0" marL="0">
-              <a:buNone/>
-            </a:pPr>
-            <a:r>
-              <a:rPr lang="en-US" sz="1350" b="1" dirty="0">
-                <a:solidFill>
-                  <a:srgbClr val="E7CD88"/>
-                </a:solidFill>
-                <a:latin typeface="Arial" pitchFamily="34" charset="0"/>
-                <a:ea typeface="Arial" pitchFamily="34" charset="-122"/>
-                <a:cs typeface="Arial" pitchFamily="34" charset="-120"/>
-              </a:rPr>
-              <a:t>Embedded Aura — in-app Q&amp;A (this demo)</a:t>
-            </a:r>
-            <a:pPr indent="0" marL="0">
-              <a:buNone/>
-            </a:pPr>
-            <a:r>
-              <a:rPr lang="en-US" sz="1350" dirty="0">
-                <a:solidFill>
-                  <a:srgbClr val="C3CCDC"/>
-                </a:solidFill>
-                <a:latin typeface="Arial" pitchFamily="34" charset="0"/>
-                <a:ea typeface="Arial" pitchFamily="34" charset="-122"/>
-                <a:cs typeface="Arial" pitchFamily="34" charset="-120"/>
-              </a:rPr>
-              <a:t>        Aura Copilot — analysts &amp; BI        Aura Code — agents &amp; MCPs</a:t>
-            </a:r>
-            <a:endParaRPr lang="en-US" sz="1350" dirty="0"/>
-          </a:p>
-        </p:txBody>
-      </p:sp>
-      <p:sp>
-        <p:nvSpPr>
-          <p:cNvPr id="13" name="Text 11"/>
-          <p:cNvSpPr/>
-          <p:nvPr/>
-        </p:nvSpPr>
-        <p:spPr>
-          <a:xfrm>
-            <a:off x="658368" y="5806440"/>
-            <a:ext cx="10972800" cy="731520"/>
+            <a:off x="4754880" y="3593592"/>
+            <a:ext cx="3108960" cy="1005840"/>
           </a:xfrm>
           <a:prstGeom prst="rect">
             <a:avLst/>
@@ -2479,7 +2513,7 @@
               <a:buNone/>
             </a:pPr>
             <a:r>
-              <a:rPr lang="en-US" sz="1450" dirty="0">
+              <a:rPr lang="en-US" sz="1350" dirty="0">
                 <a:solidFill>
                   <a:srgbClr val="8B95AB"/>
                 </a:solidFill>
@@ -2487,8 +2521,138 @@
                 <a:ea typeface="Arial" pitchFamily="34" charset="-122"/>
                 <a:cs typeface="Arial" pitchFamily="34" charset="-120"/>
               </a:rPr>
-              <a:t>Not a chatbot bolted onto a database — the </a:t>
-            </a:r>
+              <a:t>Natural-language Q&amp;A dropped inside your own app — for application users.</a:t>
+            </a:r>
+            <a:endParaRPr lang="en-US" sz="1350" dirty="0"/>
+          </a:p>
+        </p:txBody>
+      </p:sp>
+      <p:sp>
+        <p:nvSpPr>
+          <p:cNvPr id="13" name="Shape 11"/>
+          <p:cNvSpPr/>
+          <p:nvPr/>
+        </p:nvSpPr>
+        <p:spPr>
+          <a:xfrm>
+            <a:off x="8339328" y="2514600"/>
+            <a:ext cx="3566160" cy="2240280"/>
+          </a:xfrm>
+          <a:prstGeom prst="roundRect">
+            <a:avLst>
+              <a:gd name="adj" fmla="val 4898"/>
+            </a:avLst>
+          </a:prstGeom>
+          <a:solidFill>
+            <a:srgbClr val="121A2E"/>
+          </a:solidFill>
+          <a:ln w="12700">
+            <a:solidFill>
+              <a:srgbClr val="2A3350"/>
+            </a:solidFill>
+            <a:prstDash val="solid"/>
+          </a:ln>
+        </p:spPr>
+      </p:sp>
+      <p:sp>
+        <p:nvSpPr>
+          <p:cNvPr id="14" name="Text 12"/>
+          <p:cNvSpPr/>
+          <p:nvPr/>
+        </p:nvSpPr>
+        <p:spPr>
+          <a:xfrm>
+            <a:off x="8595360" y="2752344"/>
+            <a:ext cx="3108960" cy="274320"/>
+          </a:xfrm>
+          <a:prstGeom prst="rect">
+            <a:avLst/>
+          </a:prstGeom>
+          <a:noFill/>
+          <a:ln/>
+        </p:spPr>
+        <p:txBody>
+          <a:bodyPr wrap="square" rtlCol="0" anchor="ctr"/>
+          <a:lstStyle/>
+          <a:p>
+            <a:pPr indent="0" marL="0">
+              <a:buNone/>
+            </a:pPr>
+            <a:r>
+              <a:rPr lang="en-US" sz="1100" b="1" spc="150" kern="0" dirty="0">
+                <a:solidFill>
+                  <a:srgbClr val="A5B4FC"/>
+                </a:solidFill>
+                <a:latin typeface="Arial" pitchFamily="34" charset="0"/>
+                <a:ea typeface="Arial" pitchFamily="34" charset="-122"/>
+                <a:cs typeface="Arial" pitchFamily="34" charset="-120"/>
+              </a:rPr>
+              <a:t>AGENTS &amp; MCPS</a:t>
+            </a:r>
+            <a:endParaRPr lang="en-US" sz="1100" dirty="0"/>
+          </a:p>
+        </p:txBody>
+      </p:sp>
+      <p:sp>
+        <p:nvSpPr>
+          <p:cNvPr id="15" name="Text 13"/>
+          <p:cNvSpPr/>
+          <p:nvPr/>
+        </p:nvSpPr>
+        <p:spPr>
+          <a:xfrm>
+            <a:off x="8595360" y="3118104"/>
+            <a:ext cx="3108960" cy="365760"/>
+          </a:xfrm>
+          <a:prstGeom prst="rect">
+            <a:avLst/>
+          </a:prstGeom>
+          <a:noFill/>
+          <a:ln/>
+        </p:spPr>
+        <p:txBody>
+          <a:bodyPr wrap="square" rtlCol="0" anchor="ctr"/>
+          <a:lstStyle/>
+          <a:p>
+            <a:pPr indent="0" marL="0">
+              <a:buNone/>
+            </a:pPr>
+            <a:r>
+              <a:rPr lang="en-US" sz="1800" b="1" dirty="0">
+                <a:solidFill>
+                  <a:srgbClr val="E9EEF7"/>
+                </a:solidFill>
+                <a:latin typeface="Arial" pitchFamily="34" charset="0"/>
+                <a:ea typeface="Arial" pitchFamily="34" charset="-122"/>
+                <a:cs typeface="Arial" pitchFamily="34" charset="-120"/>
+              </a:rPr>
+              <a:t>Aura Code</a:t>
+            </a:r>
+            <a:endParaRPr lang="en-US" sz="1800" dirty="0"/>
+          </a:p>
+        </p:txBody>
+      </p:sp>
+      <p:sp>
+        <p:nvSpPr>
+          <p:cNvPr id="16" name="Text 14"/>
+          <p:cNvSpPr/>
+          <p:nvPr/>
+        </p:nvSpPr>
+        <p:spPr>
+          <a:xfrm>
+            <a:off x="8595360" y="3593592"/>
+            <a:ext cx="3108960" cy="1005840"/>
+          </a:xfrm>
+          <a:prstGeom prst="rect">
+            <a:avLst/>
+          </a:prstGeom>
+          <a:noFill/>
+          <a:ln/>
+        </p:spPr>
+        <p:txBody>
+          <a:bodyPr wrap="square" rtlCol="0" anchor="t"/>
+          <a:lstStyle/>
+          <a:p>
             <a:pPr indent="0" marL="0">
               <a:lnSpc>
                 <a:spcPct val="130000"/>
@@ -2496,24 +2660,7 @@
               <a:buNone/>
             </a:pPr>
             <a:r>
-              <a:rPr lang="en-US" sz="1450" b="1" dirty="0">
-                <a:solidFill>
-                  <a:srgbClr val="E9EEF7"/>
-                </a:solidFill>
-                <a:latin typeface="Arial" pitchFamily="34" charset="0"/>
-                <a:ea typeface="Arial" pitchFamily="34" charset="-122"/>
-                <a:cs typeface="Arial" pitchFamily="34" charset="-120"/>
-              </a:rPr>
-              <a:t>intelligence-first</a:t>
-            </a:r>
-            <a:pPr indent="0" marL="0">
-              <a:lnSpc>
-                <a:spcPct val="130000"/>
-              </a:lnSpc>
-              <a:buNone/>
-            </a:pPr>
-            <a:r>
-              <a:rPr lang="en-US" sz="1450" dirty="0">
+              <a:rPr lang="en-US" sz="1350" dirty="0">
                 <a:solidFill>
                   <a:srgbClr val="8B95AB"/>
                 </a:solidFill>
@@ -2521,26 +2668,48 @@
                 <a:ea typeface="Arial" pitchFamily="34" charset="-122"/>
                 <a:cs typeface="Arial" pitchFamily="34" charset="-120"/>
               </a:rPr>
-              <a:t> center of gravity. Enterprise-grade: </a:t>
-            </a:r>
-            <a:pPr indent="0" marL="0">
-              <a:lnSpc>
-                <a:spcPct val="130000"/>
-              </a:lnSpc>
-              <a:buNone/>
-            </a:pPr>
-            <a:r>
-              <a:rPr lang="en-US" sz="1450" b="1" dirty="0">
-                <a:solidFill>
-                  <a:srgbClr val="C3CCDC"/>
-                </a:solidFill>
-                <a:latin typeface="Arial" pitchFamily="34" charset="0"/>
-                <a:ea typeface="Arial" pitchFamily="34" charset="-122"/>
-                <a:cs typeface="Arial" pitchFamily="34" charset="-120"/>
-              </a:rPr>
-              <a:t>multi-tenant, robust RBAC, BYOK, observability, best-in-class accuracy.</a:t>
-            </a:r>
-            <a:endParaRPr lang="en-US" sz="1450" dirty="0"/>
+              <a:t>Custom apps &amp; agents your developers build — their UX, same Domain.</a:t>
+            </a:r>
+            <a:endParaRPr lang="en-US" sz="1350" dirty="0"/>
+          </a:p>
+        </p:txBody>
+      </p:sp>
+      <p:sp>
+        <p:nvSpPr>
+          <p:cNvPr id="17" name="Text 15"/>
+          <p:cNvSpPr/>
+          <p:nvPr/>
+        </p:nvSpPr>
+        <p:spPr>
+          <a:xfrm>
+            <a:off x="658368" y="4983480"/>
+            <a:ext cx="10972800" cy="365760"/>
+          </a:xfrm>
+          <a:prstGeom prst="rect">
+            <a:avLst/>
+          </a:prstGeom>
+          <a:noFill/>
+          <a:ln/>
+        </p:spPr>
+        <p:txBody>
+          <a:bodyPr wrap="square" rtlCol="0" anchor="ctr"/>
+          <a:lstStyle/>
+          <a:p>
+            <a:pPr indent="0" marL="0">
+              <a:buNone/>
+            </a:pPr>
+            <a:r>
+              <a:rPr lang="en-US" sz="1300" dirty="0">
+                <a:solidFill>
+                  <a:srgbClr val="8B95AB"/>
+                </a:solidFill>
+                <a:latin typeface="Arial" pitchFamily="34" charset="0"/>
+                <a:ea typeface="Arial" pitchFamily="34" charset="-122"/>
+                <a:cs typeface="Arial" pitchFamily="34" charset="-120"/>
+              </a:rPr>
+              <a:t>Shared SingleStore context engine · one governed database · live data</a:t>
+            </a:r>
+            <a:endParaRPr lang="en-US" sz="1300" dirty="0"/>
           </a:p>
         </p:txBody>
       </p:sp>
@@ -2555,6 +2724,625 @@
 <file path=ppt/slides/slide4.xml><?xml version="1.0" encoding="utf-8"?>
 <p:sld xmlns:a="http://schemas.openxmlformats.org/drawingml/2006/main" xmlns:r="http://schemas.openxmlformats.org/officeDocument/2006/relationships" xmlns:p="http://schemas.openxmlformats.org/presentationml/2006/main">
   <p:cSld name="Slide 4">
+    <p:bg>
+      <p:bgPr>
+        <a:solidFill>
+          <a:srgbClr val="070B16"/>
+        </a:solidFill>
+      </p:bgPr>
+    </p:bg>
+    <p:spTree>
+      <p:nvGrpSpPr>
+        <p:cNvPr id="1" name=""/>
+        <p:cNvGrpSpPr/>
+        <p:nvPr/>
+      </p:nvGrpSpPr>
+      <p:grpSpPr>
+        <a:xfrm>
+          <a:off x="0" y="0"/>
+          <a:ext cx="0" cy="0"/>
+          <a:chOff x="0" y="0"/>
+          <a:chExt cx="0" cy="0"/>
+        </a:xfrm>
+      </p:grpSpPr>
+      <p:sp>
+        <p:nvSpPr>
+          <p:cNvPr id="2" name="Text 0"/>
+          <p:cNvSpPr/>
+          <p:nvPr/>
+        </p:nvSpPr>
+        <p:spPr>
+          <a:xfrm>
+            <a:off x="658368" y="502920"/>
+            <a:ext cx="10972800" cy="365760"/>
+          </a:xfrm>
+          <a:prstGeom prst="rect">
+            <a:avLst/>
+          </a:prstGeom>
+          <a:noFill/>
+          <a:ln/>
+        </p:spPr>
+        <p:txBody>
+          <a:bodyPr wrap="square" rtlCol="0" anchor="ctr"/>
+          <a:lstStyle/>
+          <a:p>
+            <a:pPr indent="0" marL="0">
+              <a:buNone/>
+            </a:pPr>
+            <a:r>
+              <a:rPr lang="en-US" sz="1250" b="1" spc="300" kern="0" dirty="0">
+                <a:solidFill>
+                  <a:srgbClr val="D8B25A"/>
+                </a:solidFill>
+                <a:latin typeface="Arial" pitchFamily="34" charset="0"/>
+                <a:ea typeface="Arial" pitchFamily="34" charset="-122"/>
+                <a:cs typeface="Arial" pitchFamily="34" charset="-120"/>
+              </a:rPr>
+              <a:t>THE DOMAIN — YOUR MOAT</a:t>
+            </a:r>
+            <a:endParaRPr lang="en-US" sz="1250" dirty="0"/>
+          </a:p>
+        </p:txBody>
+      </p:sp>
+      <p:sp>
+        <p:nvSpPr>
+          <p:cNvPr id="3" name="Text 1"/>
+          <p:cNvSpPr/>
+          <p:nvPr/>
+        </p:nvSpPr>
+        <p:spPr>
+          <a:xfrm>
+            <a:off x="658368" y="1005840"/>
+            <a:ext cx="10972800" cy="1371600"/>
+          </a:xfrm>
+          <a:prstGeom prst="rect">
+            <a:avLst/>
+          </a:prstGeom>
+          <a:noFill/>
+          <a:ln/>
+        </p:spPr>
+        <p:txBody>
+          <a:bodyPr wrap="square" rtlCol="0" anchor="ctr"/>
+          <a:lstStyle/>
+          <a:p>
+            <a:pPr indent="0" marL="0">
+              <a:lnSpc>
+                <a:spcPts val="3876"/>
+              </a:lnSpc>
+              <a:buNone/>
+            </a:pPr>
+            <a:r>
+              <a:rPr lang="en-US" sz="3800" b="1" dirty="0">
+                <a:solidFill>
+                  <a:srgbClr val="E9EEF7"/>
+                </a:solidFill>
+                <a:latin typeface="Arial" pitchFamily="34" charset="0"/>
+                <a:ea typeface="Arial" pitchFamily="34" charset="-122"/>
+                <a:cs typeface="Arial" pitchFamily="34" charset="-120"/>
+              </a:rPr>
+              <a:t>One </a:t>
+            </a:r>
+            <a:pPr indent="0" marL="0">
+              <a:lnSpc>
+                <a:spcPts val="3876"/>
+              </a:lnSpc>
+              <a:buNone/>
+            </a:pPr>
+            <a:r>
+              <a:rPr lang="en-US" sz="3800" b="1" dirty="0">
+                <a:solidFill>
+                  <a:srgbClr val="D8B25A"/>
+                </a:solidFill>
+                <a:latin typeface="Arial" pitchFamily="34" charset="0"/>
+                <a:ea typeface="Arial" pitchFamily="34" charset="-122"/>
+                <a:cs typeface="Arial" pitchFamily="34" charset="-120"/>
+              </a:rPr>
+              <a:t>Domain.</a:t>
+            </a:r>
+            <a:pPr indent="0" marL="0">
+              <a:lnSpc>
+                <a:spcPts val="3876"/>
+              </a:lnSpc>
+              <a:buNone/>
+            </a:pPr>
+            <a:r>
+              <a:rPr lang="en-US" sz="3800" b="1" dirty="0">
+                <a:solidFill>
+                  <a:srgbClr val="E9EEF7"/>
+                </a:solidFill>
+                <a:latin typeface="Arial" pitchFamily="34" charset="0"/>
+                <a:ea typeface="Arial" pitchFamily="34" charset="-122"/>
+                <a:cs typeface="Arial" pitchFamily="34" charset="-120"/>
+              </a:rPr>
+              <a:t> Three layers.</a:t>
+            </a:r>
+            <a:endParaRPr lang="en-US" sz="3800" dirty="0"/>
+          </a:p>
+        </p:txBody>
+      </p:sp>
+      <p:sp>
+        <p:nvSpPr>
+          <p:cNvPr id="4" name="Text 2"/>
+          <p:cNvSpPr/>
+          <p:nvPr/>
+        </p:nvSpPr>
+        <p:spPr>
+          <a:xfrm>
+            <a:off x="658368" y="1783080"/>
+            <a:ext cx="10972800" cy="365760"/>
+          </a:xfrm>
+          <a:prstGeom prst="rect">
+            <a:avLst/>
+          </a:prstGeom>
+          <a:noFill/>
+          <a:ln/>
+        </p:spPr>
+        <p:txBody>
+          <a:bodyPr wrap="square" rtlCol="0" anchor="ctr"/>
+          <a:lstStyle/>
+          <a:p>
+            <a:pPr indent="0" marL="0">
+              <a:buNone/>
+            </a:pPr>
+            <a:r>
+              <a:rPr lang="en-US" sz="1500" dirty="0">
+                <a:solidFill>
+                  <a:srgbClr val="C3CCDC"/>
+                </a:solidFill>
+                <a:latin typeface="Arial" pitchFamily="34" charset="0"/>
+                <a:ea typeface="Arial" pitchFamily="34" charset="-122"/>
+                <a:cs typeface="Arial" pitchFamily="34" charset="-120"/>
+              </a:rPr>
+              <a:t>A logical grouping of a business subject area — shared by all three offerings.</a:t>
+            </a:r>
+            <a:endParaRPr lang="en-US" sz="1500" dirty="0"/>
+          </a:p>
+        </p:txBody>
+      </p:sp>
+      <p:sp>
+        <p:nvSpPr>
+          <p:cNvPr id="5" name="Shape 3"/>
+          <p:cNvSpPr/>
+          <p:nvPr/>
+        </p:nvSpPr>
+        <p:spPr>
+          <a:xfrm>
+            <a:off x="658368" y="2514600"/>
+            <a:ext cx="3566160" cy="2148840"/>
+          </a:xfrm>
+          <a:prstGeom prst="roundRect">
+            <a:avLst>
+              <a:gd name="adj" fmla="val 5106"/>
+            </a:avLst>
+          </a:prstGeom>
+          <a:solidFill>
+            <a:srgbClr val="121A2E"/>
+          </a:solidFill>
+          <a:ln w="12700">
+            <a:solidFill>
+              <a:srgbClr val="2A3350"/>
+            </a:solidFill>
+            <a:prstDash val="solid"/>
+          </a:ln>
+        </p:spPr>
+      </p:sp>
+      <p:sp>
+        <p:nvSpPr>
+          <p:cNvPr id="6" name="Text 4"/>
+          <p:cNvSpPr/>
+          <p:nvPr/>
+        </p:nvSpPr>
+        <p:spPr>
+          <a:xfrm>
+            <a:off x="914400" y="2770632"/>
+            <a:ext cx="3108960" cy="365760"/>
+          </a:xfrm>
+          <a:prstGeom prst="rect">
+            <a:avLst/>
+          </a:prstGeom>
+          <a:noFill/>
+          <a:ln/>
+        </p:spPr>
+        <p:txBody>
+          <a:bodyPr wrap="square" rtlCol="0" anchor="ctr"/>
+          <a:lstStyle/>
+          <a:p>
+            <a:pPr indent="0" marL="0">
+              <a:buNone/>
+            </a:pPr>
+            <a:r>
+              <a:rPr lang="en-US" sz="1600" b="1" dirty="0">
+                <a:solidFill>
+                  <a:srgbClr val="D8B25A"/>
+                </a:solidFill>
+                <a:latin typeface="Arial" pitchFamily="34" charset="0"/>
+                <a:ea typeface="Arial" pitchFamily="34" charset="-122"/>
+                <a:cs typeface="Arial" pitchFamily="34" charset="-120"/>
+              </a:rPr>
+              <a:t>1   </a:t>
+            </a:r>
+            <a:pPr indent="0" marL="0">
+              <a:buNone/>
+            </a:pPr>
+            <a:r>
+              <a:rPr lang="en-US" sz="1600" b="1" dirty="0">
+                <a:solidFill>
+                  <a:srgbClr val="E9EEF7"/>
+                </a:solidFill>
+                <a:latin typeface="Arial" pitchFamily="34" charset="0"/>
+                <a:ea typeface="Arial" pitchFamily="34" charset="-122"/>
+                <a:cs typeface="Arial" pitchFamily="34" charset="-120"/>
+              </a:rPr>
+              <a:t>SingleStore expertise</a:t>
+            </a:r>
+            <a:endParaRPr lang="en-US" sz="1600" dirty="0"/>
+          </a:p>
+        </p:txBody>
+      </p:sp>
+      <p:sp>
+        <p:nvSpPr>
+          <p:cNvPr id="7" name="Text 5"/>
+          <p:cNvSpPr/>
+          <p:nvPr/>
+        </p:nvSpPr>
+        <p:spPr>
+          <a:xfrm>
+            <a:off x="914400" y="3300984"/>
+            <a:ext cx="3108960" cy="1188720"/>
+          </a:xfrm>
+          <a:prstGeom prst="rect">
+            <a:avLst/>
+          </a:prstGeom>
+          <a:noFill/>
+          <a:ln/>
+        </p:spPr>
+        <p:txBody>
+          <a:bodyPr wrap="square" rtlCol="0" anchor="t"/>
+          <a:lstStyle/>
+          <a:p>
+            <a:pPr indent="0" marL="0">
+              <a:lnSpc>
+                <a:spcPct val="130000"/>
+              </a:lnSpc>
+              <a:buNone/>
+            </a:pPr>
+            <a:r>
+              <a:rPr lang="en-US" sz="1350" dirty="0">
+                <a:solidFill>
+                  <a:srgbClr val="8B95AB"/>
+                </a:solidFill>
+                <a:latin typeface="Arial" pitchFamily="34" charset="0"/>
+                <a:ea typeface="Arial" pitchFamily="34" charset="-122"/>
+                <a:cs typeface="Arial" pitchFamily="34" charset="-120"/>
+              </a:rPr>
+              <a:t>Knows how to write best-in-class SingleStore SQL &amp; applications.</a:t>
+            </a:r>
+            <a:endParaRPr lang="en-US" sz="1350" dirty="0"/>
+          </a:p>
+        </p:txBody>
+      </p:sp>
+      <p:sp>
+        <p:nvSpPr>
+          <p:cNvPr id="8" name="Shape 6"/>
+          <p:cNvSpPr/>
+          <p:nvPr/>
+        </p:nvSpPr>
+        <p:spPr>
+          <a:xfrm>
+            <a:off x="4498848" y="2514600"/>
+            <a:ext cx="3566160" cy="2148840"/>
+          </a:xfrm>
+          <a:prstGeom prst="roundRect">
+            <a:avLst>
+              <a:gd name="adj" fmla="val 5106"/>
+            </a:avLst>
+          </a:prstGeom>
+          <a:solidFill>
+            <a:srgbClr val="121A2E"/>
+          </a:solidFill>
+          <a:ln w="12700">
+            <a:solidFill>
+              <a:srgbClr val="2A3350"/>
+            </a:solidFill>
+            <a:prstDash val="solid"/>
+          </a:ln>
+        </p:spPr>
+      </p:sp>
+      <p:sp>
+        <p:nvSpPr>
+          <p:cNvPr id="9" name="Text 7"/>
+          <p:cNvSpPr/>
+          <p:nvPr/>
+        </p:nvSpPr>
+        <p:spPr>
+          <a:xfrm>
+            <a:off x="4754880" y="2770632"/>
+            <a:ext cx="3108960" cy="365760"/>
+          </a:xfrm>
+          <a:prstGeom prst="rect">
+            <a:avLst/>
+          </a:prstGeom>
+          <a:noFill/>
+          <a:ln/>
+        </p:spPr>
+        <p:txBody>
+          <a:bodyPr wrap="square" rtlCol="0" anchor="ctr"/>
+          <a:lstStyle/>
+          <a:p>
+            <a:pPr indent="0" marL="0">
+              <a:buNone/>
+            </a:pPr>
+            <a:r>
+              <a:rPr lang="en-US" sz="1600" b="1" dirty="0">
+                <a:solidFill>
+                  <a:srgbClr val="D8B25A"/>
+                </a:solidFill>
+                <a:latin typeface="Arial" pitchFamily="34" charset="0"/>
+                <a:ea typeface="Arial" pitchFamily="34" charset="-122"/>
+                <a:cs typeface="Arial" pitchFamily="34" charset="-120"/>
+              </a:rPr>
+              <a:t>2   </a:t>
+            </a:r>
+            <a:pPr indent="0" marL="0">
+              <a:buNone/>
+            </a:pPr>
+            <a:r>
+              <a:rPr lang="en-US" sz="1600" b="1" dirty="0">
+                <a:solidFill>
+                  <a:srgbClr val="E9EEF7"/>
+                </a:solidFill>
+                <a:latin typeface="Arial" pitchFamily="34" charset="0"/>
+                <a:ea typeface="Arial" pitchFamily="34" charset="-122"/>
+                <a:cs typeface="Arial" pitchFamily="34" charset="-120"/>
+              </a:rPr>
+              <a:t>Business ontology</a:t>
+            </a:r>
+            <a:endParaRPr lang="en-US" sz="1600" dirty="0"/>
+          </a:p>
+        </p:txBody>
+      </p:sp>
+      <p:sp>
+        <p:nvSpPr>
+          <p:cNvPr id="10" name="Text 8"/>
+          <p:cNvSpPr/>
+          <p:nvPr/>
+        </p:nvSpPr>
+        <p:spPr>
+          <a:xfrm>
+            <a:off x="4754880" y="3300984"/>
+            <a:ext cx="3108960" cy="1188720"/>
+          </a:xfrm>
+          <a:prstGeom prst="rect">
+            <a:avLst/>
+          </a:prstGeom>
+          <a:noFill/>
+          <a:ln/>
+        </p:spPr>
+        <p:txBody>
+          <a:bodyPr wrap="square" rtlCol="0" anchor="t"/>
+          <a:lstStyle/>
+          <a:p>
+            <a:pPr indent="0" marL="0">
+              <a:lnSpc>
+                <a:spcPct val="130000"/>
+              </a:lnSpc>
+              <a:buNone/>
+            </a:pPr>
+            <a:r>
+              <a:rPr lang="en-US" sz="1350" dirty="0">
+                <a:solidFill>
+                  <a:srgbClr val="8B95AB"/>
+                </a:solidFill>
+                <a:latin typeface="Arial" pitchFamily="34" charset="0"/>
+                <a:ea typeface="Arial" pitchFamily="34" charset="-122"/>
+                <a:cs typeface="Arial" pitchFamily="34" charset="-120"/>
+              </a:rPr>
+              <a:t>Captures your business rules &amp; vocabulary — your metrics, your definitions.</a:t>
+            </a:r>
+            <a:endParaRPr lang="en-US" sz="1350" dirty="0"/>
+          </a:p>
+        </p:txBody>
+      </p:sp>
+      <p:sp>
+        <p:nvSpPr>
+          <p:cNvPr id="11" name="Shape 9"/>
+          <p:cNvSpPr/>
+          <p:nvPr/>
+        </p:nvSpPr>
+        <p:spPr>
+          <a:xfrm>
+            <a:off x="8339328" y="2514600"/>
+            <a:ext cx="3566160" cy="2148840"/>
+          </a:xfrm>
+          <a:prstGeom prst="roundRect">
+            <a:avLst>
+              <a:gd name="adj" fmla="val 5106"/>
+            </a:avLst>
+          </a:prstGeom>
+          <a:solidFill>
+            <a:srgbClr val="121A2E"/>
+          </a:solidFill>
+          <a:ln w="12700">
+            <a:solidFill>
+              <a:srgbClr val="2A3350"/>
+            </a:solidFill>
+            <a:prstDash val="solid"/>
+          </a:ln>
+        </p:spPr>
+      </p:sp>
+      <p:sp>
+        <p:nvSpPr>
+          <p:cNvPr id="12" name="Text 10"/>
+          <p:cNvSpPr/>
+          <p:nvPr/>
+        </p:nvSpPr>
+        <p:spPr>
+          <a:xfrm>
+            <a:off x="8595360" y="2770632"/>
+            <a:ext cx="3108960" cy="365760"/>
+          </a:xfrm>
+          <a:prstGeom prst="rect">
+            <a:avLst/>
+          </a:prstGeom>
+          <a:noFill/>
+          <a:ln/>
+        </p:spPr>
+        <p:txBody>
+          <a:bodyPr wrap="square" rtlCol="0" anchor="ctr"/>
+          <a:lstStyle/>
+          <a:p>
+            <a:pPr indent="0" marL="0">
+              <a:buNone/>
+            </a:pPr>
+            <a:r>
+              <a:rPr lang="en-US" sz="1600" b="1" dirty="0">
+                <a:solidFill>
+                  <a:srgbClr val="D8B25A"/>
+                </a:solidFill>
+                <a:latin typeface="Arial" pitchFamily="34" charset="0"/>
+                <a:ea typeface="Arial" pitchFamily="34" charset="-122"/>
+                <a:cs typeface="Arial" pitchFamily="34" charset="-120"/>
+              </a:rPr>
+              <a:t>3   </a:t>
+            </a:r>
+            <a:pPr indent="0" marL="0">
+              <a:buNone/>
+            </a:pPr>
+            <a:r>
+              <a:rPr lang="en-US" sz="1600" b="1" dirty="0">
+                <a:solidFill>
+                  <a:srgbClr val="E9EEF7"/>
+                </a:solidFill>
+                <a:latin typeface="Arial" pitchFamily="34" charset="0"/>
+                <a:ea typeface="Arial" pitchFamily="34" charset="-122"/>
+                <a:cs typeface="Arial" pitchFamily="34" charset="-120"/>
+              </a:rPr>
+              <a:t>Technical semantic</a:t>
+            </a:r>
+            <a:endParaRPr lang="en-US" sz="1600" dirty="0"/>
+          </a:p>
+        </p:txBody>
+      </p:sp>
+      <p:sp>
+        <p:nvSpPr>
+          <p:cNvPr id="13" name="Text 11"/>
+          <p:cNvSpPr/>
+          <p:nvPr/>
+        </p:nvSpPr>
+        <p:spPr>
+          <a:xfrm>
+            <a:off x="8595360" y="3300984"/>
+            <a:ext cx="3108960" cy="1188720"/>
+          </a:xfrm>
+          <a:prstGeom prst="rect">
+            <a:avLst/>
+          </a:prstGeom>
+          <a:noFill/>
+          <a:ln/>
+        </p:spPr>
+        <p:txBody>
+          <a:bodyPr wrap="square" rtlCol="0" anchor="t"/>
+          <a:lstStyle/>
+          <a:p>
+            <a:pPr indent="0" marL="0">
+              <a:lnSpc>
+                <a:spcPct val="130000"/>
+              </a:lnSpc>
+              <a:buNone/>
+            </a:pPr>
+            <a:r>
+              <a:rPr lang="en-US" sz="1350" dirty="0">
+                <a:solidFill>
+                  <a:srgbClr val="8B95AB"/>
+                </a:solidFill>
+                <a:latin typeface="Arial" pitchFamily="34" charset="0"/>
+                <a:ea typeface="Arial" pitchFamily="34" charset="-122"/>
+                <a:cs typeface="Arial" pitchFamily="34" charset="-120"/>
+              </a:rPr>
+              <a:t>Auto-derived from your schema &amp; kept current as your data evolves.</a:t>
+            </a:r>
+            <a:endParaRPr lang="en-US" sz="1350" dirty="0"/>
+          </a:p>
+        </p:txBody>
+      </p:sp>
+      <p:sp>
+        <p:nvSpPr>
+          <p:cNvPr id="14" name="Text 12"/>
+          <p:cNvSpPr/>
+          <p:nvPr/>
+        </p:nvSpPr>
+        <p:spPr>
+          <a:xfrm>
+            <a:off x="658368" y="4937760"/>
+            <a:ext cx="10972800" cy="457200"/>
+          </a:xfrm>
+          <a:prstGeom prst="rect">
+            <a:avLst/>
+          </a:prstGeom>
+          <a:noFill/>
+          <a:ln/>
+        </p:spPr>
+        <p:txBody>
+          <a:bodyPr wrap="square" rtlCol="0" anchor="ctr"/>
+          <a:lstStyle/>
+          <a:p>
+            <a:pPr indent="0" marL="0">
+              <a:buNone/>
+            </a:pPr>
+            <a:r>
+              <a:rPr lang="en-US" sz="1800" dirty="0">
+                <a:solidFill>
+                  <a:srgbClr val="C3CCDC"/>
+                </a:solidFill>
+                <a:latin typeface="Arial" pitchFamily="34" charset="0"/>
+                <a:ea typeface="Arial" pitchFamily="34" charset="-122"/>
+                <a:cs typeface="Arial" pitchFamily="34" charset="-120"/>
+              </a:rPr>
+              <a:t>Same model, same data — the </a:t>
+            </a:r>
+            <a:pPr indent="0" marL="0">
+              <a:buNone/>
+            </a:pPr>
+            <a:r>
+              <a:rPr lang="en-US" sz="1800" b="1" dirty="0">
+                <a:solidFill>
+                  <a:srgbClr val="E7CD88"/>
+                </a:solidFill>
+                <a:latin typeface="Arial" pitchFamily="34" charset="0"/>
+                <a:ea typeface="Arial" pitchFamily="34" charset="-122"/>
+                <a:cs typeface="Arial" pitchFamily="34" charset="-120"/>
+              </a:rPr>
+              <a:t>Domain is the difference.</a:t>
+            </a:r>
+            <a:pPr indent="0" marL="0">
+              <a:buNone/>
+            </a:pPr>
+            <a:r>
+              <a:rPr lang="en-US" sz="1800" dirty="0">
+                <a:solidFill>
+                  <a:srgbClr val="C3CCDC"/>
+                </a:solidFill>
+                <a:latin typeface="Arial" pitchFamily="34" charset="0"/>
+                <a:ea typeface="Arial" pitchFamily="34" charset="-122"/>
+                <a:cs typeface="Arial" pitchFamily="34" charset="-120"/>
+              </a:rPr>
+              <a:t> Context is the moat.</a:t>
+            </a:r>
+            <a:endParaRPr lang="en-US" sz="1800" dirty="0"/>
+          </a:p>
+        </p:txBody>
+      </p:sp>
+    </p:spTree>
+  </p:cSld>
+  <p:clrMapOvr>
+    <a:masterClrMapping/>
+  </p:clrMapOvr>
+</p:sld>
+</file>
+
+<file path=ppt/slides/slide5.xml><?xml version="1.0" encoding="utf-8"?>
+<p:sld xmlns:a="http://schemas.openxmlformats.org/drawingml/2006/main" xmlns:r="http://schemas.openxmlformats.org/officeDocument/2006/relationships" xmlns:p="http://schemas.openxmlformats.org/presentationml/2006/main">
+  <p:cSld name="Slide 5">
     <p:bg>
       <p:bgPr>
         <a:solidFill>

</xml_diff>